<commit_message>
Reflow tuning-duration and SQL-execution charts into quarter-slide figures
</commit_message>
<xml_diff>
--- a/design/patent-timeout-feedback-figures/pptx/fig8-tuning-duration.pptx
+++ b/design/patent-timeout-feedback-figures/pptx/fig8-tuning-duration.pptx
@@ -13,6 +13,312 @@
   <p:sldSz cx="12192000" cy="6858000"/>
   <p:notesSz cx="6858000" cy="9144000"/>
 </p:presentation>
+</file>
+
+<file path=ppt/charts/chart101.xml><?xml version="1.0" encoding="utf-8"?>
+<c:chartSpace xmlns:c="http://schemas.openxmlformats.org/drawingml/2006/chart" xmlns:a="http://schemas.openxmlformats.org/drawingml/2006/main" xmlns:r="http://schemas.openxmlformats.org/officeDocument/2006/relationships">
+  <c:date1904 val="0"/>
+  <c:lang val="zh-CN"/>
+  <c:chart>
+    <c:autoTitleDeleted val="1"/>
+    <c:plotArea>
+      <c:layout>
+        <c:manualLayout>
+          <c:layoutTarget val="inner"/>
+          <c:xMode val="edge"/>
+          <c:yMode val="edge"/>
+          <c:wMode val="factor"/>
+          <c:hMode val="factor"/>
+          <c:x val="0.0822368421053"/>
+          <c:y val="0.0677966101695"/>
+          <c:w val="0.894736842105"/>
+          <c:h val="0.796610169492"/>
+        </c:manualLayout>
+      </c:layout>
+      <c:barChart>
+        <c:barDir val="col"/>
+        <c:grouping val="clustered"/>
+        <c:varyColors val="0"/>
+        <c:ser>
+          <c:idx val="0"/>
+          <c:order val="0"/>
+          <c:tx>
+            <c:strRef>
+              <c:f>Sheet1!$B$1</c:f>
+              <c:strCache>
+                <c:ptCount val="1"/>
+                <c:pt idx="0">
+                  <c:v>不设单轮超时</c:v>
+                </c:pt>
+              </c:strCache>
+            </c:strRef>
+          </c:tx>
+          <c:spPr>
+            <a:solidFill>
+              <a:srgbClr val="98A4AC"/>
+            </a:solidFill>
+            <a:ln>
+              <a:solidFill>
+                <a:srgbClr val="98A4AC"/>
+              </a:solidFill>
+            </a:ln>
+          </c:spPr>
+          <c:invertIfNegative val="0"/>
+          <c:cat>
+            <c:strRef>
+              <c:f>Sheet1!$A$2:$A$3</c:f>
+              <c:strCache>
+                <c:ptCount val="2"/>
+                <c:pt idx="0">
+                  <c:v>JOB（113条）</c:v>
+                </c:pt>
+                <c:pt idx="1">
+                  <c:v>JOB-complex（30条）</c:v>
+                </c:pt>
+              </c:strCache>
+            </c:strRef>
+          </c:cat>
+          <c:val>
+            <c:numRef>
+              <c:f>Sheet1!$B$2:$B$3</c:f>
+              <c:numCache>
+                <c:formatCode>General</c:formatCode>
+                <c:ptCount val="2"/>
+                <c:pt idx="0">
+                  <c:v>2348</c:v>
+                </c:pt>
+                <c:pt idx="1">
+                  <c:v>1002</c:v>
+                </c:pt>
+              </c:numCache>
+            </c:numRef>
+          </c:val>
+        </c:ser>
+        <c:ser>
+          <c:idx val="1"/>
+          <c:order val="1"/>
+          <c:tx>
+            <c:strRef>
+              <c:f>Sheet1!$C$1</c:f>
+              <c:strCache>
+                <c:ptCount val="1"/>
+                <c:pt idx="0">
+                  <c:v>单轮10秒部分反馈</c:v>
+                </c:pt>
+              </c:strCache>
+            </c:strRef>
+          </c:tx>
+          <c:spPr>
+            <a:solidFill>
+              <a:srgbClr val="2C5C84"/>
+            </a:solidFill>
+            <a:ln>
+              <a:solidFill>
+                <a:srgbClr val="2C5C84"/>
+              </a:solidFill>
+            </a:ln>
+          </c:spPr>
+          <c:invertIfNegative val="0"/>
+          <c:cat>
+            <c:strRef>
+              <c:f>Sheet1!$A$2:$A$3</c:f>
+              <c:strCache>
+                <c:ptCount val="2"/>
+                <c:pt idx="0">
+                  <c:v>JOB（113条）</c:v>
+                </c:pt>
+                <c:pt idx="1">
+                  <c:v>JOB-complex（30条）</c:v>
+                </c:pt>
+              </c:strCache>
+            </c:strRef>
+          </c:cat>
+          <c:val>
+            <c:numRef>
+              <c:f>Sheet1!$C$2:$C$3</c:f>
+              <c:numCache>
+                <c:formatCode>General</c:formatCode>
+                <c:ptCount val="2"/>
+                <c:pt idx="0">
+                  <c:v>1599</c:v>
+                </c:pt>
+                <c:pt idx="1">
+                  <c:v>583</c:v>
+                </c:pt>
+              </c:numCache>
+            </c:numRef>
+          </c:val>
+        </c:ser>
+        <c:dLbls>
+          <c:numFmt formatCode="#,##0" sourceLinked="0"/>
+          <c:txPr>
+            <a:bodyPr/>
+            <a:lstStyle/>
+            <a:p>
+              <a:pPr>
+                <a:defRPr lang="zh-CN" sz="1280" b="1">
+                  <a:solidFill>
+                    <a:srgbClr val="24313A"/>
+                  </a:solidFill>
+                  <a:latin typeface="Microsoft YaHei"/>
+                  <a:ea typeface="Microsoft YaHei"/>
+                  <a:cs typeface="Microsoft YaHei"/>
+                </a:defRPr>
+              </a:pPr>
+              <a:endParaRPr lang="zh-CN"/>
+            </a:p>
+          </c:txPr>
+          <c:dLblPos val="outEnd"/>
+          <c:showLegendKey val="0"/>
+          <c:showVal val="1"/>
+          <c:showCatName val="0"/>
+          <c:showSerName val="0"/>
+          <c:showPercent val="0"/>
+          <c:showBubbleSize val="0"/>
+          <c:showLeaderLines val="0"/>
+        </c:dLbls>
+        <c:gapWidth val="100"/>
+        <c:overlap val="-15"/>
+        <c:axId val="2068027336"/>
+        <c:axId val="2113994440"/>
+      </c:barChart>
+      <c:catAx>
+        <c:axId val="2068027336"/>
+        <c:scaling>
+          <c:orientation val="minMax"/>
+        </c:scaling>
+        <c:delete val="0"/>
+        <c:axPos val="b"/>
+        <c:numFmt formatCode="General" sourceLinked="0"/>
+        <c:majorTickMark val="none"/>
+        <c:minorTickMark val="none"/>
+        <c:tickLblPos val="nextTo"/>
+        <c:spPr>
+          <a:ln w="9525" cap="flat" cmpd="sng" algn="ctr">
+            <a:solidFill>
+              <a:srgbClr val="63717B"/>
+            </a:solidFill>
+            <a:round/>
+          </a:ln>
+        </c:spPr>
+        <c:txPr>
+          <a:bodyPr/>
+          <a:lstStyle/>
+          <a:p>
+            <a:pPr>
+              <a:defRPr lang="zh-CN" sz="1120">
+                <a:solidFill>
+                  <a:srgbClr val="24313A"/>
+                </a:solidFill>
+                <a:latin typeface="Microsoft YaHei"/>
+                <a:ea typeface="Microsoft YaHei"/>
+                <a:cs typeface="Microsoft YaHei"/>
+              </a:defRPr>
+            </a:pPr>
+            <a:endParaRPr lang="zh-CN"/>
+          </a:p>
+        </c:txPr>
+        <c:crossAx val="2113994440"/>
+        <c:crosses val="autoZero"/>
+        <c:auto val="1"/>
+        <c:lblAlgn val="ctr"/>
+        <c:lblOffset val="100"/>
+        <c:noMultiLvlLbl val="0"/>
+      </c:catAx>
+      <c:valAx>
+        <c:axId val="2113994440"/>
+        <c:scaling>
+          <c:orientation val="minMax"/>
+          <c:max val="2500"/>
+          <c:min val="0"/>
+        </c:scaling>
+        <c:delete val="0"/>
+        <c:axPos val="l"/>
+        <c:majorGridlines>
+          <c:spPr>
+            <a:ln w="6350" cap="flat" cmpd="sng" algn="ctr">
+              <a:solidFill>
+                <a:srgbClr val="D5DDE2"/>
+              </a:solidFill>
+              <a:round/>
+            </a:ln>
+          </c:spPr>
+        </c:majorGridlines>
+        <c:numFmt formatCode="#,##0" sourceLinked="0"/>
+        <c:majorTickMark val="none"/>
+        <c:minorTickMark val="none"/>
+        <c:tickLblPos val="nextTo"/>
+        <c:spPr>
+          <a:ln w="9525" cap="flat" cmpd="sng" algn="ctr">
+            <a:solidFill>
+              <a:srgbClr val="63717B"/>
+            </a:solidFill>
+            <a:round/>
+          </a:ln>
+        </c:spPr>
+        <c:txPr>
+          <a:bodyPr/>
+          <a:lstStyle/>
+          <a:p>
+            <a:pPr>
+              <a:defRPr lang="zh-CN" sz="1050">
+                <a:solidFill>
+                  <a:srgbClr val="63717B"/>
+                </a:solidFill>
+                <a:latin typeface="Microsoft YaHei"/>
+                <a:ea typeface="Microsoft YaHei"/>
+                <a:cs typeface="Microsoft YaHei"/>
+              </a:defRPr>
+            </a:pPr>
+            <a:endParaRPr lang="zh-CN"/>
+          </a:p>
+        </c:txPr>
+        <c:crossAx val="2068027336"/>
+        <c:crosses val="autoZero"/>
+        <c:crossBetween val="between"/>
+        <c:majorUnit val="500"/>
+      </c:valAx>
+      <c:spPr>
+        <a:solidFill>
+          <a:srgbClr val="FFFFFF"/>
+        </a:solidFill>
+        <a:ln>
+          <a:noFill/>
+        </a:ln>
+      </c:spPr>
+    </c:plotArea>
+    <c:plotVisOnly val="1"/>
+    <c:dispBlanksAs val="gap"/>
+  </c:chart>
+  <c:spPr>
+    <a:solidFill>
+      <a:srgbClr val="FFFFFF"/>
+    </a:solidFill>
+    <a:ln>
+      <a:noFill/>
+    </a:ln>
+  </c:spPr>
+  <c:txPr>
+    <a:bodyPr/>
+    <a:lstStyle/>
+    <a:p>
+      <a:pPr>
+        <a:defRPr lang="zh-CN" sz="900">
+          <a:solidFill>
+            <a:srgbClr val="24313A"/>
+          </a:solidFill>
+          <a:latin typeface="Microsoft YaHei"/>
+          <a:ea typeface="Microsoft YaHei"/>
+          <a:cs typeface="Microsoft YaHei"/>
+        </a:defRPr>
+      </a:pPr>
+      <a:endParaRPr lang="zh-CN"/>
+    </a:p>
+  </c:txPr>
+  <c:externalData r:id="rId1">
+    <c:autoUpdate val="0"/>
+  </c:externalData>
+</c:chartSpace>
 </file>
 
 <file path=ppt/notesMasters/notesMaster1.xml><?xml version="1.0" encoding="utf-8"?>
@@ -2693,222 +2999,12 @@
 </a:theme>
 </file>
 
-<file path=ppt/slides/charts/chart1.xml><?xml version="1.0" encoding="utf-8"?>
-<c:chartSpace xmlns:c="http://schemas.openxmlformats.org/drawingml/2006/chart">
-  <c:lang val="en-US"/>
-  <c:chart>
-    <c:plotArea>
-      <c:barChart>
-        <c:barDir val="col"/>
-        <c:grouping val="clustered"/>
-        <c:varyColors val="0"/>
-        <c:ser>
-          <c:idx val="0"/>
-          <c:order val="0"/>
-          <c:tx>
-            <c:v>不设单轮超时</c:v>
-          </c:tx>
-          <c:spPr>
-            <a:solidFill xmlns:a="http://schemas.openxmlformats.org/drawingml/2006/main">
-              <a:srgbClr val="98A4AC"/>
-            </a:solidFill>
-          </c:spPr>
-          <c:cat>
-            <c:strLit>
-              <c:ptCount val="2"/>
-              <c:pt idx="0">
-                <c:v>JOB（113 条）</c:v>
-              </c:pt>
-              <c:pt idx="1">
-                <c:v>JOB-complex（30 条）</c:v>
-              </c:pt>
-            </c:strLit>
-          </c:cat>
-          <c:val>
-            <c:numLit>
-              <c:formatCode>#,##0</c:formatCode>
-              <c:ptCount val="2"/>
-              <c:pt idx="0">
-                <c:v>2348</c:v>
-              </c:pt>
-              <c:pt idx="1">
-                <c:v>1002</c:v>
-              </c:pt>
-            </c:numLit>
-          </c:val>
-        </c:ser>
-        <c:ser>
-          <c:idx val="1"/>
-          <c:order val="1"/>
-          <c:tx>
-            <c:v>单轮 10 秒部分反馈</c:v>
-          </c:tx>
-          <c:spPr>
-            <a:solidFill xmlns:a="http://schemas.openxmlformats.org/drawingml/2006/main">
-              <a:srgbClr val="2C5C84"/>
-            </a:solidFill>
-          </c:spPr>
-          <c:cat>
-            <c:strLit>
-              <c:ptCount val="2"/>
-              <c:pt idx="0">
-                <c:v>JOB（113 条）</c:v>
-              </c:pt>
-              <c:pt idx="1">
-                <c:v>JOB-complex（30 条）</c:v>
-              </c:pt>
-            </c:strLit>
-          </c:cat>
-          <c:val>
-            <c:numLit>
-              <c:formatCode>#,##0</c:formatCode>
-              <c:ptCount val="2"/>
-              <c:pt idx="0">
-                <c:v>1599</c:v>
-              </c:pt>
-              <c:pt idx="1">
-                <c:v>583</c:v>
-              </c:pt>
-            </c:numLit>
-          </c:val>
-        </c:ser>
-        <c:dLbls>
-          <c:numFmt formatCode="#,##0" sourceLinked="0"/>
-          <c:txPr>
-            <a:bodyPr xmlns:a="http://schemas.openxmlformats.org/drawingml/2006/main" anchorCtr="1"/>
-            <a:lstStyle xmlns:a="http://schemas.openxmlformats.org/drawingml/2006/main"/>
-            <a:p xmlns:a="http://schemas.openxmlformats.org/drawingml/2006/main">
-              <a:pPr>
-                <a:defRPr sz="975">
-                  <a:solidFill>
-                    <a:srgbClr val="24313A"/>
-                  </a:solidFill>
-                  <a:latin typeface="Microsoft YaHei"/>
-                  <a:ea typeface="Microsoft YaHei"/>
-                  <a:cs typeface="Microsoft YaHei"/>
-                </a:defRPr>
-              </a:pPr>
-            </a:p>
-          </c:txPr>
-          <c:dLblPos val="outEnd"/>
-          <c:showLegendKey val="0"/>
-          <c:showVal val="1"/>
-          <c:showCatName val="0"/>
-          <c:showSerName val="0"/>
-          <c:showPercent val="0"/>
-          <c:showBubbleSize val="0"/>
-          <c:showLeaderLines val="0"/>
-        </c:dLbls>
-        <c:gapWidth val="180"/>
-        <c:overlap val="0"/>
-        <c:axId val="48650112"/>
-        <c:axId val="48672768"/>
-      </c:barChart>
-      <c:catAx>
-        <c:axId val="48650112"/>
-        <c:scaling>
-          <c:orientation val="minMax"/>
-        </c:scaling>
-        <c:delete val="0"/>
-        <c:axPos val="b"/>
-        <c:numFmt formatCode="General"/>
-        <c:majorTickMark val="none"/>
-        <c:minorTickMark val="none"/>
-        <c:spPr>
-          <a:ln xmlns:a="http://schemas.openxmlformats.org/drawingml/2006/main" w="9525">
-            <a:solidFill>
-              <a:srgbClr val="63717B"/>
-            </a:solidFill>
-          </a:ln>
-        </c:spPr>
-        <c:txPr>
-          <a:bodyPr xmlns:a="http://schemas.openxmlformats.org/drawingml/2006/main" anchorCtr="1"/>
-          <a:lstStyle xmlns:a="http://schemas.openxmlformats.org/drawingml/2006/main"/>
-          <a:p xmlns:a="http://schemas.openxmlformats.org/drawingml/2006/main">
-            <a:pPr>
-              <a:defRPr sz="900">
-                <a:solidFill>
-                  <a:srgbClr val="24313A"/>
-                </a:solidFill>
-                <a:latin typeface="Microsoft YaHei"/>
-                <a:ea typeface="Microsoft YaHei"/>
-                <a:cs typeface="Microsoft YaHei"/>
-              </a:defRPr>
-            </a:pPr>
-          </a:p>
-        </c:txPr>
-        <c:crossAx val="48672768"/>
-      </c:catAx>
-      <c:valAx>
-        <c:axId val="48672768"/>
-        <c:scaling>
-          <c:orientation val="minMax"/>
-          <c:max val="2500"/>
-          <c:min val="0"/>
-        </c:scaling>
-        <c:delete val="0"/>
-        <c:axPos val="l"/>
-        <c:majorGridlines>
-          <c:spPr>
-            <a:ln xmlns:a="http://schemas.openxmlformats.org/drawingml/2006/main" w="7144">
-              <a:solidFill>
-                <a:srgbClr val="D5DDE2"/>
-              </a:solidFill>
-            </a:ln>
-          </c:spPr>
-        </c:majorGridlines>
-        <c:numFmt formatCode="#,##0"/>
-        <c:majorTickMark val="none"/>
-        <c:minorTickMark val="none"/>
-        <c:spPr>
-          <a:ln xmlns:a="http://schemas.openxmlformats.org/drawingml/2006/main" w="9525">
-            <a:solidFill>
-              <a:srgbClr val="63717B"/>
-            </a:solidFill>
-          </a:ln>
-        </c:spPr>
-        <c:txPr>
-          <a:bodyPr xmlns:a="http://schemas.openxmlformats.org/drawingml/2006/main" anchorCtr="1"/>
-          <a:lstStyle xmlns:a="http://schemas.openxmlformats.org/drawingml/2006/main"/>
-          <a:p xmlns:a="http://schemas.openxmlformats.org/drawingml/2006/main">
-            <a:pPr>
-              <a:defRPr sz="863">
-                <a:solidFill>
-                  <a:srgbClr val="63717B"/>
-                </a:solidFill>
-                <a:latin typeface="Microsoft YaHei"/>
-                <a:ea typeface="Microsoft YaHei"/>
-                <a:cs typeface="Microsoft YaHei"/>
-              </a:defRPr>
-            </a:pPr>
-          </a:p>
-        </c:txPr>
-        <c:crossAx val="48650112"/>
-        <c:crossBetween val="between"/>
-        <c:majorUnit val="500"/>
-      </c:valAx>
-      <c:spPr>
-        <a:solidFill xmlns:a="http://schemas.openxmlformats.org/drawingml/2006/main">
-          <a:srgbClr val="FFFFFF"/>
-        </a:solidFill>
-      </c:spPr>
-    </c:plotArea>
-    <c:plotVisOnly val="1"/>
-  </c:chart>
-  <c:spPr>
-    <a:solidFill xmlns:a="http://schemas.openxmlformats.org/drawingml/2006/main">
-      <a:srgbClr val="FFFFFF"/>
-    </a:solidFill>
-  </c:spPr>
-</c:chartSpace>
-</file>
-
 <file path=ppt/slides/slide1.xml><?xml version="1.0" encoding="utf-8"?>
-<p:sld xmlns:p="http://schemas.openxmlformats.org/presentationml/2006/main">
+<p:sld xmlns:a="http://schemas.openxmlformats.org/drawingml/2006/main" xmlns:c="http://schemas.openxmlformats.org/drawingml/2006/chart" xmlns:p="http://schemas.openxmlformats.org/presentationml/2006/main" xmlns:p14="http://schemas.microsoft.com/office/powerpoint/2010/main" xmlns:r="http://schemas.openxmlformats.org/officeDocument/2006/relationships">
   <p:cSld>
     <p:bg>
       <p:bgPr>
-        <a:solidFill xmlns:a="http://schemas.openxmlformats.org/drawingml/2006/main">
+        <a:solidFill>
           <a:srgbClr val="FFFFFF"/>
         </a:solidFill>
       </p:bgPr>
@@ -2920,68 +3016,36 @@
         <p:nvPr/>
       </p:nvGrpSpPr>
       <p:grpSpPr>
-        <a:xfrm xmlns:a="http://schemas.openxmlformats.org/drawingml/2006/main"/>
+        <a:xfrm/>
       </p:grpSpPr>
       <p:sp>
         <p:nvSpPr>
-          <p:cNvPr id="6" name="title">
-            <a:extLst xmlns:a="http://schemas.openxmlformats.org/drawingml/2006/main">
-              <a:ext uri="{FF2B5EF4-FFF2-40B4-BE49-F238E27FC236}">
-                <a16:creationId xmlns:a16="http://schemas.microsoft.com/office/drawing/2014/main" id="{3824703A-8ADE-4726-ACFD-0A4429E7232A}"/>
-              </a:ext>
-            </a:extLst>
-          </p:cNvPr>
-          <p:cNvSpPr>
-            <a:spLocks xmlns:a="http://schemas.openxmlformats.org/drawingml/2006/main" noGrp="1"/>
-          </p:cNvSpPr>
+          <p:cNvPr id="6" name="title"/>
+          <p:cNvSpPr/>
           <p:nvPr/>
         </p:nvSpPr>
         <p:spPr>
-          <a:xfrm xmlns:a="http://schemas.openxmlformats.org/drawingml/2006/main">
-            <a:off x="323850" y="2333625"/>
-            <a:ext cx="2952750" cy="200025"/>
+          <a:xfrm>
+            <a:off x="3200400" y="1828800"/>
+            <a:ext cx="5791200" cy="276225"/>
           </a:xfrm>
-          <a:prstGeom xmlns:a="http://schemas.openxmlformats.org/drawingml/2006/main" prst="rect">
+          <a:prstGeom prst="rect">
             <a:avLst/>
           </a:prstGeom>
-          <a:noFill xmlns:a="http://schemas.openxmlformats.org/drawingml/2006/main"/>
-          <a:ln xmlns:a="http://schemas.openxmlformats.org/drawingml/2006/main" w="0">
+          <a:noFill/>
+          <a:ln>
             <a:noFill/>
           </a:ln>
         </p:spPr>
         <p:txBody>
-          <a:bodyPr xmlns:a="http://schemas.openxmlformats.org/drawingml/2006/main" wrap="none" lIns="0" tIns="0" rIns="0" bIns="0" anchor="t">
+          <a:bodyPr wrap="none" lIns="0" tIns="30004" rIns="0" bIns="0" anchor="t" anchorCtr="0">
             <a:noAutofit/>
           </a:bodyPr>
-          <a:lstStyle xmlns:a="http://schemas.openxmlformats.org/drawingml/2006/main">
-            <a:defPPr algn="l">
-              <a:defRPr sz="1200" b="1">
-                <a:solidFill>
-                  <a:srgbClr val="24313A"/>
-                </a:solidFill>
-                <a:latin typeface="Microsoft YaHei"/>
-                <a:ea typeface="Microsoft YaHei"/>
-                <a:cs typeface="Microsoft YaHei"/>
-              </a:defRPr>
-            </a:defPPr>
-          </a:lstStyle>
-          <a:p xmlns:a="http://schemas.openxmlformats.org/drawingml/2006/main">
-            <a:pPr algn="l">
-              <a:lnSpc>
-                <a:spcPct val="100000"/>
-              </a:lnSpc>
-              <a:buNone/>
-              <a:defRPr sz="1200" b="1">
-                <a:solidFill>
-                  <a:srgbClr val="24313A"/>
-                </a:solidFill>
-                <a:latin typeface="Microsoft YaHei"/>
-                <a:ea typeface="Microsoft YaHei"/>
-                <a:cs typeface="Microsoft YaHei"/>
-              </a:defRPr>
-            </a:pPr>
+          <a:lstStyle/>
+          <a:p>
+            <a:pPr algn="l"/>
             <a:r>
-              <a:rPr sz="1200" b="1">
+              <a:rPr lang="zh-CN" sz="1580" b="1" dirty="0">
                 <a:solidFill>
                   <a:srgbClr val="24313A"/>
                 </a:solidFill>
@@ -2989,71 +3053,39 @@
                 <a:ea typeface="Microsoft YaHei"/>
                 <a:cs typeface="Microsoft YaHei"/>
               </a:rPr>
-              <a:t>调优总时长（秒）</a:t>
+              <a:t>调优总时长对比（秒）</a:t>
             </a:r>
           </a:p>
         </p:txBody>
       </p:sp>
       <p:sp>
         <p:nvSpPr>
-          <p:cNvPr id="2" name="legend1">
-            <a:extLst xmlns:a="http://schemas.openxmlformats.org/drawingml/2006/main">
-              <a:ext uri="{FF2B5EF4-FFF2-40B4-BE49-F238E27FC236}">
-                <a16:creationId xmlns:a16="http://schemas.microsoft.com/office/drawing/2014/main" id="{753CC834-030C-4C99-92E4-9BE9E3A464E1}"/>
-              </a:ext>
-            </a:extLst>
-          </p:cNvPr>
-          <p:cNvSpPr>
-            <a:spLocks xmlns:a="http://schemas.openxmlformats.org/drawingml/2006/main" noGrp="1"/>
-          </p:cNvSpPr>
+          <p:cNvPr id="2" name="legend1"/>
+          <p:cNvSpPr/>
           <p:nvPr/>
         </p:nvSpPr>
         <p:spPr>
-          <a:xfrm xmlns:a="http://schemas.openxmlformats.org/drawingml/2006/main">
-            <a:off x="6334125" y="2343150"/>
-            <a:ext cx="2524125" cy="161925"/>
+          <a:xfrm>
+            <a:off x="3390900" y="2143125"/>
+            <a:ext cx="2133600" cy="219075"/>
           </a:xfrm>
-          <a:prstGeom xmlns:a="http://schemas.openxmlformats.org/drawingml/2006/main" prst="rect">
+          <a:prstGeom prst="rect">
             <a:avLst/>
           </a:prstGeom>
-          <a:noFill xmlns:a="http://schemas.openxmlformats.org/drawingml/2006/main"/>
-          <a:ln xmlns:a="http://schemas.openxmlformats.org/drawingml/2006/main" w="0">
+          <a:noFill/>
+          <a:ln>
             <a:noFill/>
           </a:ln>
         </p:spPr>
         <p:txBody>
-          <a:bodyPr xmlns:a="http://schemas.openxmlformats.org/drawingml/2006/main" wrap="none" lIns="0" tIns="0" rIns="0" bIns="0" anchor="t">
+          <a:bodyPr wrap="none" lIns="0" tIns="21431" rIns="0" bIns="0" anchor="t" anchorCtr="0">
             <a:noAutofit/>
           </a:bodyPr>
-          <a:lstStyle xmlns:a="http://schemas.openxmlformats.org/drawingml/2006/main">
-            <a:defPPr algn="l">
-              <a:defRPr sz="975" b="0">
-                <a:solidFill>
-                  <a:srgbClr val="24313A"/>
-                </a:solidFill>
-                <a:latin typeface="Microsoft YaHei"/>
-                <a:ea typeface="Microsoft YaHei"/>
-                <a:cs typeface="Microsoft YaHei"/>
-              </a:defRPr>
-            </a:defPPr>
-          </a:lstStyle>
-          <a:p xmlns:a="http://schemas.openxmlformats.org/drawingml/2006/main">
-            <a:pPr algn="l">
-              <a:lnSpc>
-                <a:spcPct val="100000"/>
-              </a:lnSpc>
-              <a:buNone/>
-              <a:defRPr sz="975" b="0">
-                <a:solidFill>
-                  <a:srgbClr val="24313A"/>
-                </a:solidFill>
-                <a:latin typeface="Microsoft YaHei"/>
-                <a:ea typeface="Microsoft YaHei"/>
-                <a:cs typeface="Microsoft YaHei"/>
-              </a:defRPr>
-            </a:pPr>
+          <a:lstStyle/>
+          <a:p>
+            <a:pPr algn="l"/>
             <a:r>
-              <a:rPr sz="975" b="0">
+              <a:rPr lang="zh-CN" sz="1120" dirty="0">
                 <a:solidFill>
                   <a:srgbClr val="24313A"/>
                 </a:solidFill>
@@ -3061,71 +3093,39 @@
                 <a:ea typeface="Microsoft YaHei"/>
                 <a:cs typeface="Microsoft YaHei"/>
               </a:rPr>
-              <a:t>灰色：不设单轮超时</a:t>
+              <a:t>不设单轮超时</a:t>
             </a:r>
           </a:p>
         </p:txBody>
       </p:sp>
       <p:sp>
         <p:nvSpPr>
-          <p:cNvPr id="3" name="legend2">
-            <a:extLst xmlns:a="http://schemas.openxmlformats.org/drawingml/2006/main">
-              <a:ext uri="{FF2B5EF4-FFF2-40B4-BE49-F238E27FC236}">
-                <a16:creationId xmlns:a16="http://schemas.microsoft.com/office/drawing/2014/main" id="{65574FCC-1855-4657-B36C-0543286DB6AC}"/>
-              </a:ext>
-            </a:extLst>
-          </p:cNvPr>
-          <p:cNvSpPr>
-            <a:spLocks xmlns:a="http://schemas.openxmlformats.org/drawingml/2006/main" noGrp="1"/>
-          </p:cNvSpPr>
+          <p:cNvPr id="3" name="legend2"/>
+          <p:cNvSpPr/>
           <p:nvPr/>
         </p:nvSpPr>
         <p:spPr>
-          <a:xfrm xmlns:a="http://schemas.openxmlformats.org/drawingml/2006/main">
-            <a:off x="9029700" y="2343150"/>
-            <a:ext cx="2857500" cy="161925"/>
+          <a:xfrm>
+            <a:off x="6153150" y="2143125"/>
+            <a:ext cx="2838450" cy="219075"/>
           </a:xfrm>
-          <a:prstGeom xmlns:a="http://schemas.openxmlformats.org/drawingml/2006/main" prst="rect">
+          <a:prstGeom prst="rect">
             <a:avLst/>
           </a:prstGeom>
-          <a:noFill xmlns:a="http://schemas.openxmlformats.org/drawingml/2006/main"/>
-          <a:ln xmlns:a="http://schemas.openxmlformats.org/drawingml/2006/main" w="0">
+          <a:noFill/>
+          <a:ln>
             <a:noFill/>
           </a:ln>
         </p:spPr>
         <p:txBody>
-          <a:bodyPr xmlns:a="http://schemas.openxmlformats.org/drawingml/2006/main" wrap="none" lIns="0" tIns="0" rIns="0" bIns="0" anchor="t">
+          <a:bodyPr wrap="none" lIns="0" tIns="21431" rIns="0" bIns="0" anchor="t" anchorCtr="0">
             <a:noAutofit/>
           </a:bodyPr>
-          <a:lstStyle xmlns:a="http://schemas.openxmlformats.org/drawingml/2006/main">
-            <a:defPPr algn="l">
-              <a:defRPr sz="975" b="0">
-                <a:solidFill>
-                  <a:srgbClr val="24313A"/>
-                </a:solidFill>
-                <a:latin typeface="Microsoft YaHei"/>
-                <a:ea typeface="Microsoft YaHei"/>
-                <a:cs typeface="Microsoft YaHei"/>
-              </a:defRPr>
-            </a:defPPr>
-          </a:lstStyle>
-          <a:p xmlns:a="http://schemas.openxmlformats.org/drawingml/2006/main">
-            <a:pPr algn="l">
-              <a:lnSpc>
-                <a:spcPct val="100000"/>
-              </a:lnSpc>
-              <a:buNone/>
-              <a:defRPr sz="975" b="0">
-                <a:solidFill>
-                  <a:srgbClr val="24313A"/>
-                </a:solidFill>
-                <a:latin typeface="Microsoft YaHei"/>
-                <a:ea typeface="Microsoft YaHei"/>
-                <a:cs typeface="Microsoft YaHei"/>
-              </a:defRPr>
-            </a:pPr>
+          <a:lstStyle/>
+          <a:p>
+            <a:pPr algn="l"/>
             <a:r>
-              <a:rPr sz="975" b="0">
+              <a:rPr lang="zh-CN" sz="1120" dirty="0">
                 <a:solidFill>
                   <a:srgbClr val="24313A"/>
                 </a:solidFill>
@@ -3133,109 +3133,187 @@
                 <a:ea typeface="Microsoft YaHei"/>
                 <a:cs typeface="Microsoft YaHei"/>
               </a:rPr>
-              <a:t>蓝色：单轮 10 秒部分反馈</a:t>
+              <a:t>单轮10秒部分反馈</a:t>
             </a:r>
           </a:p>
         </p:txBody>
       </p:sp>
       <p:graphicFrame>
         <p:nvGraphicFramePr>
-          <p:cNvPr id="4" name="Chart">
-            <a:extLst xmlns:a="http://schemas.openxmlformats.org/drawingml/2006/main">
-              <a:ext uri="{FF2B5EF4-FFF2-40B4-BE49-F238E27FC236}">
-                <a16:creationId xmlns:a16="http://schemas.microsoft.com/office/drawing/2014/main" id="{78812FF7-AC30-4AAF-8479-D847BE1DC1D4}"/>
-              </a:ext>
-            </a:extLst>
-          </p:cNvPr>
-          <p:cNvGraphicFramePr/>
+          <p:cNvPr id="10" name="figure-8-4-comparison"/>
+          <p:cNvGraphicFramePr>
+            <a:graphicFrameLocks noGrp="1"/>
+          </p:cNvGraphicFramePr>
           <p:nvPr/>
         </p:nvGraphicFramePr>
         <p:xfrm>
-          <a:off xmlns:a="http://schemas.openxmlformats.org/drawingml/2006/main" x="285750" y="2571750"/>
-          <a:ext xmlns:a="http://schemas.openxmlformats.org/drawingml/2006/main" cx="11620500" cy="1685925"/>
+          <a:off x="3200400" y="2400300"/>
+          <a:ext cx="5791200" cy="2247900"/>
         </p:xfrm>
-        <a:graphic xmlns:a="http://schemas.openxmlformats.org/drawingml/2006/main">
+        <a:graphic>
           <a:graphicData uri="http://schemas.openxmlformats.org/drawingml/2006/chart">
-            <c:chart xmlns:r="http://schemas.openxmlformats.org/officeDocument/2006/relationships" xmlns:c="http://schemas.openxmlformats.org/drawingml/2006/chart" r:id="Red7711ee10b14be2"/>
+            <c:chart r:id="rId2"/>
           </a:graphicData>
         </a:graphic>
       </p:graphicFrame>
       <p:sp>
         <p:nvSpPr>
-          <p:cNvPr id="5" name="footnote">
-            <a:extLst xmlns:a="http://schemas.openxmlformats.org/drawingml/2006/main">
-              <a:ext uri="{FF2B5EF4-FFF2-40B4-BE49-F238E27FC236}">
-                <a16:creationId xmlns:a16="http://schemas.microsoft.com/office/drawing/2014/main" id="{34853193-5AEA-44D5-AD0A-2F83B7A3C435}"/>
-              </a:ext>
-            </a:extLst>
-          </p:cNvPr>
-          <p:cNvSpPr>
-            <a:spLocks xmlns:a="http://schemas.openxmlformats.org/drawingml/2006/main" noGrp="1"/>
-          </p:cNvSpPr>
+          <p:cNvPr id="5" name="footnote"/>
+          <p:cNvSpPr/>
           <p:nvPr/>
         </p:nvSpPr>
         <p:spPr>
-          <a:xfrm xmlns:a="http://schemas.openxmlformats.org/drawingml/2006/main">
-            <a:off x="323850" y="4400550"/>
-            <a:ext cx="11525250" cy="142875"/>
+          <a:xfrm>
+            <a:off x="3200400" y="4724400"/>
+            <a:ext cx="5791200" cy="381000"/>
           </a:xfrm>
-          <a:prstGeom xmlns:a="http://schemas.openxmlformats.org/drawingml/2006/main" prst="rect">
+          <a:prstGeom prst="rect">
             <a:avLst/>
           </a:prstGeom>
-          <a:noFill xmlns:a="http://schemas.openxmlformats.org/drawingml/2006/main"/>
-          <a:ln xmlns:a="http://schemas.openxmlformats.org/drawingml/2006/main" w="0">
+          <a:noFill/>
+          <a:ln>
             <a:noFill/>
           </a:ln>
         </p:spPr>
         <p:txBody>
-          <a:bodyPr xmlns:a="http://schemas.openxmlformats.org/drawingml/2006/main" wrap="none" lIns="0" tIns="0" rIns="0" bIns="0" anchor="t">
+          <a:bodyPr wrap="none" lIns="0" tIns="19288" rIns="0" bIns="0" anchor="t" anchorCtr="0">
             <a:noAutofit/>
           </a:bodyPr>
-          <a:lstStyle xmlns:a="http://schemas.openxmlformats.org/drawingml/2006/main">
-            <a:defPPr algn="l">
-              <a:defRPr sz="863" b="0">
-                <a:solidFill>
-                  <a:srgbClr val="24313A"/>
-                </a:solidFill>
-                <a:latin typeface="Microsoft YaHei"/>
-                <a:ea typeface="Microsoft YaHei"/>
-                <a:cs typeface="Microsoft YaHei"/>
-              </a:defRPr>
-            </a:defPPr>
-          </a:lstStyle>
-          <a:p xmlns:a="http://schemas.openxmlformats.org/drawingml/2006/main">
+          <a:lstStyle/>
+          <a:p>
             <a:pPr algn="l">
               <a:lnSpc>
-                <a:spcPct val="100000"/>
-              </a:lnSpc>
-              <a:buNone/>
-              <a:defRPr sz="863" b="0">
-                <a:solidFill>
-                  <a:srgbClr val="24313A"/>
-                </a:solidFill>
-                <a:latin typeface="Microsoft YaHei"/>
-                <a:ea typeface="Microsoft YaHei"/>
-                <a:cs typeface="Microsoft YaHei"/>
-              </a:defRPr>
+                <a:spcPts val="1468"/>
+              </a:lnSpc>
             </a:pPr>
             <a:r>
-              <a:rPr sz="863" b="0">
+              <a:rPr lang="zh-CN" sz="1010" dirty="0">
                 <a:solidFill>
-                  <a:srgbClr val="24313A"/>
+                  <a:srgbClr val="63717B"/>
                 </a:solidFill>
                 <a:latin typeface="Microsoft YaHei"/>
                 <a:ea typeface="Microsoft YaHei"/>
                 <a:cs typeface="Microsoft YaHei"/>
               </a:rPr>
-              <a:t>每条 SQL 的全局搜索预算为 300 秒，patience-iters=5；两组使用不同代码版本。</a:t>
+              <a:t>每条SQL的全局搜索预算为300秒，patience-iters=5；</a:t>
+            </a:r>
+            <a:br/>
+            <a:r>
+              <a:rPr lang="zh-CN" sz="1010" dirty="0">
+                <a:solidFill>
+                  <a:srgbClr val="63717B"/>
+                </a:solidFill>
+                <a:latin typeface="Microsoft YaHei"/>
+                <a:ea typeface="Microsoft YaHei"/>
+                <a:cs typeface="Microsoft YaHei"/>
+              </a:rPr>
+              <a:t>两组使用不同代码版本。</a:t>
             </a:r>
           </a:p>
         </p:txBody>
       </p:sp>
+      <p:grpSp>
+        <p:nvGrpSpPr>
+          <p:cNvPr id="13" name="legend-no-timeout"/>
+          <p:cNvGrpSpPr/>
+          <p:nvPr/>
+        </p:nvGrpSpPr>
+        <p:grpSpPr>
+          <a:xfrm>
+            <a:off x="3200400" y="2190750"/>
+            <a:ext cx="114300" cy="114300"/>
+            <a:chOff x="3200400" y="2190750"/>
+            <a:chExt cx="114300" cy="114300"/>
+          </a:xfrm>
+        </p:grpSpPr>
+        <p:sp>
+          <p:nvSpPr>
+            <p:cNvPr id="12" name="Rectangle 12"/>
+            <p:cNvSpPr/>
+            <p:nvPr/>
+          </p:nvSpPr>
+          <p:spPr>
+            <a:xfrm>
+              <a:off x="3200400" y="2190750"/>
+              <a:ext cx="114300" cy="114300"/>
+            </a:xfrm>
+            <a:prstGeom prst="rect">
+              <a:avLst/>
+            </a:prstGeom>
+            <a:solidFill>
+              <a:srgbClr val="98A4AC"/>
+            </a:solidFill>
+            <a:ln>
+              <a:noFill/>
+            </a:ln>
+          </p:spPr>
+        </p:sp>
+      </p:grpSp>
+      <p:grpSp>
+        <p:nvGrpSpPr>
+          <p:cNvPr id="15" name="legend-partial"/>
+          <p:cNvGrpSpPr/>
+          <p:nvPr/>
+        </p:nvGrpSpPr>
+        <p:grpSpPr>
+          <a:xfrm>
+            <a:off x="5962650" y="2190750"/>
+            <a:ext cx="114300" cy="114300"/>
+            <a:chOff x="5962650" y="2190750"/>
+            <a:chExt cx="114300" cy="114300"/>
+          </a:xfrm>
+        </p:grpSpPr>
+        <p:sp>
+          <p:nvSpPr>
+            <p:cNvPr id="14" name="Rectangle 14"/>
+            <p:cNvSpPr/>
+            <p:nvPr/>
+          </p:nvSpPr>
+          <p:spPr>
+            <a:xfrm>
+              <a:off x="5962650" y="2190750"/>
+              <a:ext cx="114300" cy="114300"/>
+            </a:xfrm>
+            <a:prstGeom prst="rect">
+              <a:avLst/>
+            </a:prstGeom>
+            <a:solidFill>
+              <a:srgbClr val="2C5C84"/>
+            </a:solidFill>
+            <a:ln>
+              <a:noFill/>
+            </a:ln>
+          </p:spPr>
+        </p:sp>
+      </p:grpSp>
+      <p:sp>
+        <p:nvSpPr>
+          <p:cNvPr id="16" name="quarter-page-fit-frame"/>
+          <p:cNvSpPr/>
+          <p:nvPr/>
+        </p:nvSpPr>
+        <p:spPr>
+          <a:xfrm>
+            <a:off x="3048000" y="1714500"/>
+            <a:ext cx="6096000" cy="3429000"/>
+          </a:xfrm>
+          <a:prstGeom prst="rect">
+            <a:avLst/>
+          </a:prstGeom>
+          <a:solidFill>
+            <a:srgbClr val="FFFFFF">
+              <a:alpha val="0"/>
+            </a:srgbClr>
+          </a:solidFill>
+          <a:ln>
+            <a:noFill/>
+          </a:ln>
+        </p:spPr>
+      </p:sp>
     </p:spTree>
     <p:extLst>
       <p:ext uri="{BB962C8B-B14F-4D97-AF65-F5344CB8AC3E}">
-        <p14:creationId xmlns:p14="http://schemas.microsoft.com/office/powerpoint/2010/main" val="992597184"/>
+        <p14:creationId val="992597184"/>
       </p:ext>
     </p:extLst>
   </p:cSld>

</xml_diff>